<commit_message>
docs: align judge README and delivery with demonstrated evidence
</commit_message>
<xml_diff>
--- a/submission/presentation.pptx
+++ b/submission/presentation.pptx
@@ -2,21 +2,21 @@
 <file path=ppt/presentation.xml><?xml version="1.0" encoding="utf-8"?>
 <p:presentation xmlns:p="http://schemas.openxmlformats.org/presentationml/2006/main">
   <p:sldMasterIdLst>
-    <p:sldMasterId xmlns:r="http://schemas.openxmlformats.org/officeDocument/2006/relationships" id="2147483648" r:id="R29cbc556ff4244a3"/>
+    <p:sldMasterId xmlns:r="http://schemas.openxmlformats.org/officeDocument/2006/relationships" id="2147483648" r:id="Rb94c4d7dd7df49ca"/>
   </p:sldMasterIdLst>
   <p:notesMasterIdLst>
-    <p:notesMasterId xmlns:r="http://schemas.openxmlformats.org/officeDocument/2006/relationships" r:id="Rf355fcba1afe4bb2"/>
+    <p:notesMasterId xmlns:r="http://schemas.openxmlformats.org/officeDocument/2006/relationships" r:id="R7be97486b9ba4e39"/>
   </p:notesMasterIdLst>
   <p:sldIdLst>
-    <p:sldId xmlns:r="http://schemas.openxmlformats.org/officeDocument/2006/relationships" id="256" r:id="R20bffb519943451b"/>
-    <p:sldId xmlns:r="http://schemas.openxmlformats.org/officeDocument/2006/relationships" id="257" r:id="R2901d2a6da4144ae"/>
-    <p:sldId xmlns:r="http://schemas.openxmlformats.org/officeDocument/2006/relationships" id="258" r:id="Rb764db69f2504d2e"/>
-    <p:sldId xmlns:r="http://schemas.openxmlformats.org/officeDocument/2006/relationships" id="259" r:id="Rfee9853983fc4a07"/>
-    <p:sldId xmlns:r="http://schemas.openxmlformats.org/officeDocument/2006/relationships" id="260" r:id="Rca2e54c67ae7499a"/>
-    <p:sldId xmlns:r="http://schemas.openxmlformats.org/officeDocument/2006/relationships" id="261" r:id="Rafc00de50f77470d"/>
-    <p:sldId xmlns:r="http://schemas.openxmlformats.org/officeDocument/2006/relationships" id="262" r:id="R9d5e629144c94608"/>
-    <p:sldId xmlns:r="http://schemas.openxmlformats.org/officeDocument/2006/relationships" id="263" r:id="Ra503c51748a74842"/>
-    <p:sldId xmlns:r="http://schemas.openxmlformats.org/officeDocument/2006/relationships" id="264" r:id="Rb815466139234912"/>
+    <p:sldId xmlns:r="http://schemas.openxmlformats.org/officeDocument/2006/relationships" id="256" r:id="Rcc4cd8d915054199"/>
+    <p:sldId xmlns:r="http://schemas.openxmlformats.org/officeDocument/2006/relationships" id="257" r:id="R997d5ca7c73449f3"/>
+    <p:sldId xmlns:r="http://schemas.openxmlformats.org/officeDocument/2006/relationships" id="258" r:id="Ra9e6a1a03fef4ab3"/>
+    <p:sldId xmlns:r="http://schemas.openxmlformats.org/officeDocument/2006/relationships" id="259" r:id="R9ffe863e3bf34f93"/>
+    <p:sldId xmlns:r="http://schemas.openxmlformats.org/officeDocument/2006/relationships" id="260" r:id="R7120b3c9465c45a1"/>
+    <p:sldId xmlns:r="http://schemas.openxmlformats.org/officeDocument/2006/relationships" id="261" r:id="R1c2bf52b6ef0447e"/>
+    <p:sldId xmlns:r="http://schemas.openxmlformats.org/officeDocument/2006/relationships" id="262" r:id="Rff9dffdf4f8a4ef1"/>
+    <p:sldId xmlns:r="http://schemas.openxmlformats.org/officeDocument/2006/relationships" id="263" r:id="R936ade4290124cf7"/>
+    <p:sldId xmlns:r="http://schemas.openxmlformats.org/officeDocument/2006/relationships" id="264" r:id="Rce5f192fe1394479"/>
   </p:sldIdLst>
   <p:sldSz cx="12192000" cy="6858000"/>
   <p:notesSz cx="6858000" cy="9144000"/>
@@ -465,7 +465,7 @@
           </a:p>
           <a:p xmlns:a="http://schemas.openxmlformats.org/drawingml/2006/main">
             <a:r>
-              <a:t>Retained original proof date: 2026-10-04T01:29:53.383Z. Retained intention proof date: 2026-10-04T02:07:09.266Z. Browser capture date: 2026-10-04T07:54:36.814Z. Source revision: 44c57cde5aeab97ff9bd1eaef20bbde4221b10a3. Capture scope: Current judge-story UI rendering of a consistent SQLite snapshot of the retained actual hosted run360c040e-16a1-4f81-ac76-1e1ec4ef6195. Authenticated GET-only loopback capture; model generation disabled, non-GET host routes rejected. No new inference, rebind or save. Previous public-input/control screenshots and actual composition/backup retain original dates; deployment UI banner is concurrently owned..</a:t>
+              <a:t>Retained original proof date: 2026-10-04T01:29:53.383Z. Retained intention proof date: 2026-10-04T02:07:09.266Z. Browser capture date: 2026-10-04T07:54:36.814Z. Source revision: f1565c23ff185cb87587c6108be96dbec243b5ce. Capture scope: Current judge-story UI rendering of a consistent SQLite snapshot of the retained actual hosted run360c040e-16a1-4f81-ac76-1e1ec4ef6195. Authenticated GET-only loopback capture; model generation disabled, non-GET host routes rejected. No new inference, rebind or save. Previous public-input/control screenshots and actual composition/backup retain original dates; deployment UI banner is concurrently owned.; README-only documentary rebind to this revision; UI bytes identical to44c; no new capture/inference/rebind/save.</a:t>
             </a:r>
           </a:p>
           <a:p xmlns:a="http://schemas.openxmlformats.org/drawingml/2006/main">
@@ -555,7 +555,7 @@
           </a:p>
           <a:p xmlns:a="http://schemas.openxmlformats.org/drawingml/2006/main">
             <a:r>
-              <a:t>Retained original proof date: 2026-10-04T01:29:53.383Z. Retained intention proof date: 2026-10-04T02:07:09.266Z. Browser capture date: 2026-10-04T07:54:36.814Z. Source revision: 44c57cde5aeab97ff9bd1eaef20bbde4221b10a3. Capture scope: Current judge-story UI rendering of a consistent SQLite snapshot of the retained actual hosted run360c040e-16a1-4f81-ac76-1e1ec4ef6195. Authenticated GET-only loopback capture; model generation disabled, non-GET host routes rejected. No new inference, rebind or save. Previous public-input/control screenshots and actual composition/backup retain original dates; deployment UI banner is concurrently owned..</a:t>
+              <a:t>Retained original proof date: 2026-10-04T01:29:53.383Z. Retained intention proof date: 2026-10-04T02:07:09.266Z. Browser capture date: 2026-10-04T07:54:36.814Z. Source revision: f1565c23ff185cb87587c6108be96dbec243b5ce. Capture scope: Current judge-story UI rendering of a consistent SQLite snapshot of the retained actual hosted run360c040e-16a1-4f81-ac76-1e1ec4ef6195. Authenticated GET-only loopback capture; model generation disabled, non-GET host routes rejected. No new inference, rebind or save. Previous public-input/control screenshots and actual composition/backup retain original dates; deployment UI banner is concurrently owned.; README-only documentary rebind to this revision; UI bytes identical to44c; no new capture/inference/rebind/save.</a:t>
             </a:r>
           </a:p>
           <a:p xmlns:a="http://schemas.openxmlformats.org/drawingml/2006/main">
@@ -645,7 +645,7 @@
           </a:p>
           <a:p xmlns:a="http://schemas.openxmlformats.org/drawingml/2006/main">
             <a:r>
-              <a:t>Retained original proof date: 2026-10-04T01:29:53.383Z. Retained intention proof date: 2026-10-04T02:07:09.266Z. Browser capture date: 2026-10-04T07:54:36.814Z. Source revision: 44c57cde5aeab97ff9bd1eaef20bbde4221b10a3. Capture scope: Current judge-story UI rendering of a consistent SQLite snapshot of the retained actual hosted run360c040e-16a1-4f81-ac76-1e1ec4ef6195. Authenticated GET-only loopback capture; model generation disabled, non-GET host routes rejected. No new inference, rebind or save. Previous public-input/control screenshots and actual composition/backup retain original dates; deployment UI banner is concurrently owned..</a:t>
+              <a:t>Retained original proof date: 2026-10-04T01:29:53.383Z. Retained intention proof date: 2026-10-04T02:07:09.266Z. Browser capture date: 2026-10-04T07:54:36.814Z. Source revision: f1565c23ff185cb87587c6108be96dbec243b5ce. Capture scope: Current judge-story UI rendering of a consistent SQLite snapshot of the retained actual hosted run360c040e-16a1-4f81-ac76-1e1ec4ef6195. Authenticated GET-only loopback capture; model generation disabled, non-GET host routes rejected. No new inference, rebind or save. Previous public-input/control screenshots and actual composition/backup retain original dates; deployment UI banner is concurrently owned.; README-only documentary rebind to this revision; UI bytes identical to44c; no new capture/inference/rebind/save.</a:t>
             </a:r>
           </a:p>
           <a:p xmlns:a="http://schemas.openxmlformats.org/drawingml/2006/main">
@@ -735,7 +735,7 @@
           </a:p>
           <a:p xmlns:a="http://schemas.openxmlformats.org/drawingml/2006/main">
             <a:r>
-              <a:t>Retained original proof date: 2026-10-04T01:29:53.383Z. Retained intention proof date: 2026-10-04T02:07:09.266Z. Browser capture date: 2026-10-04T07:54:36.814Z. Source revision: 44c57cde5aeab97ff9bd1eaef20bbde4221b10a3. Capture scope: Current judge-story UI rendering of a consistent SQLite snapshot of the retained actual hosted run360c040e-16a1-4f81-ac76-1e1ec4ef6195. Authenticated GET-only loopback capture; model generation disabled, non-GET host routes rejected. No new inference, rebind or save. Previous public-input/control screenshots and actual composition/backup retain original dates; deployment UI banner is concurrently owned..</a:t>
+              <a:t>Retained original proof date: 2026-10-04T01:29:53.383Z. Retained intention proof date: 2026-10-04T02:07:09.266Z. Browser capture date: 2026-10-04T07:54:36.814Z. Source revision: f1565c23ff185cb87587c6108be96dbec243b5ce. Capture scope: Current judge-story UI rendering of a consistent SQLite snapshot of the retained actual hosted run360c040e-16a1-4f81-ac76-1e1ec4ef6195. Authenticated GET-only loopback capture; model generation disabled, non-GET host routes rejected. No new inference, rebind or save. Previous public-input/control screenshots and actual composition/backup retain original dates; deployment UI banner is concurrently owned.; README-only documentary rebind to this revision; UI bytes identical to44c; no new capture/inference/rebind/save.</a:t>
             </a:r>
           </a:p>
           <a:p xmlns:a="http://schemas.openxmlformats.org/drawingml/2006/main">
@@ -825,7 +825,7 @@
           </a:p>
           <a:p xmlns:a="http://schemas.openxmlformats.org/drawingml/2006/main">
             <a:r>
-              <a:t>Retained original proof date: 2026-10-04T01:29:53.383Z. Retained intention proof date: 2026-10-04T02:07:09.266Z. Browser capture date: 2026-10-04T07:54:36.814Z. Source revision: 44c57cde5aeab97ff9bd1eaef20bbde4221b10a3. Capture scope: Current judge-story UI rendering of a consistent SQLite snapshot of the retained actual hosted run360c040e-16a1-4f81-ac76-1e1ec4ef6195. Authenticated GET-only loopback capture; model generation disabled, non-GET host routes rejected. No new inference, rebind or save. Previous public-input/control screenshots and actual composition/backup retain original dates; deployment UI banner is concurrently owned..</a:t>
+              <a:t>Retained original proof date: 2026-10-04T01:29:53.383Z. Retained intention proof date: 2026-10-04T02:07:09.266Z. Browser capture date: 2026-10-04T07:54:36.814Z. Source revision: f1565c23ff185cb87587c6108be96dbec243b5ce. Capture scope: Current judge-story UI rendering of a consistent SQLite snapshot of the retained actual hosted run360c040e-16a1-4f81-ac76-1e1ec4ef6195. Authenticated GET-only loopback capture; model generation disabled, non-GET host routes rejected. No new inference, rebind or save. Previous public-input/control screenshots and actual composition/backup retain original dates; deployment UI banner is concurrently owned.; README-only documentary rebind to this revision; UI bytes identical to44c; no new capture/inference/rebind/save.</a:t>
             </a:r>
           </a:p>
           <a:p xmlns:a="http://schemas.openxmlformats.org/drawingml/2006/main">
@@ -915,7 +915,7 @@
           </a:p>
           <a:p xmlns:a="http://schemas.openxmlformats.org/drawingml/2006/main">
             <a:r>
-              <a:t>Retained original proof date: 2026-10-04T01:29:53.383Z. Retained intention proof date: 2026-10-04T02:07:09.266Z. Browser capture date: 2026-10-04T07:54:36.814Z. Source revision: 44c57cde5aeab97ff9bd1eaef20bbde4221b10a3. Capture scope: Current judge-story UI rendering of a consistent SQLite snapshot of the retained actual hosted run360c040e-16a1-4f81-ac76-1e1ec4ef6195. Authenticated GET-only loopback capture; model generation disabled, non-GET host routes rejected. No new inference, rebind or save. Previous public-input/control screenshots and actual composition/backup retain original dates; deployment UI banner is concurrently owned..</a:t>
+              <a:t>Retained original proof date: 2026-10-04T01:29:53.383Z. Retained intention proof date: 2026-10-04T02:07:09.266Z. Browser capture date: 2026-10-04T07:54:36.814Z. Source revision: f1565c23ff185cb87587c6108be96dbec243b5ce. Capture scope: Current judge-story UI rendering of a consistent SQLite snapshot of the retained actual hosted run360c040e-16a1-4f81-ac76-1e1ec4ef6195. Authenticated GET-only loopback capture; model generation disabled, non-GET host routes rejected. No new inference, rebind or save. Previous public-input/control screenshots and actual composition/backup retain original dates; deployment UI banner is concurrently owned.; README-only documentary rebind to this revision; UI bytes identical to44c; no new capture/inference/rebind/save.</a:t>
             </a:r>
           </a:p>
           <a:p xmlns:a="http://schemas.openxmlformats.org/drawingml/2006/main">
@@ -1005,7 +1005,7 @@
           </a:p>
           <a:p xmlns:a="http://schemas.openxmlformats.org/drawingml/2006/main">
             <a:r>
-              <a:t>Retained original proof date: 2026-10-04T01:29:53.383Z. Retained intention proof date: 2026-10-04T02:07:09.266Z. Browser capture date: 2026-10-04T07:54:36.814Z. Source revision: 44c57cde5aeab97ff9bd1eaef20bbde4221b10a3. Capture scope: Current judge-story UI rendering of a consistent SQLite snapshot of the retained actual hosted run360c040e-16a1-4f81-ac76-1e1ec4ef6195. Authenticated GET-only loopback capture; model generation disabled, non-GET host routes rejected. No new inference, rebind or save. Previous public-input/control screenshots and actual composition/backup retain original dates; deployment UI banner is concurrently owned..</a:t>
+              <a:t>Retained original proof date: 2026-10-04T01:29:53.383Z. Retained intention proof date: 2026-10-04T02:07:09.266Z. Browser capture date: 2026-10-04T07:54:36.814Z. Source revision: f1565c23ff185cb87587c6108be96dbec243b5ce. Capture scope: Current judge-story UI rendering of a consistent SQLite snapshot of the retained actual hosted run360c040e-16a1-4f81-ac76-1e1ec4ef6195. Authenticated GET-only loopback capture; model generation disabled, non-GET host routes rejected. No new inference, rebind or save. Previous public-input/control screenshots and actual composition/backup retain original dates; deployment UI banner is concurrently owned.; README-only documentary rebind to this revision; UI bytes identical to44c; no new capture/inference/rebind/save.</a:t>
             </a:r>
           </a:p>
           <a:p xmlns:a="http://schemas.openxmlformats.org/drawingml/2006/main">
@@ -1095,7 +1095,7 @@
           </a:p>
           <a:p xmlns:a="http://schemas.openxmlformats.org/drawingml/2006/main">
             <a:r>
-              <a:t>Retained original proof date: 2026-10-04T01:29:53.383Z. Retained intention proof date: 2026-10-04T02:07:09.266Z. Browser capture date: 2026-10-04T07:54:36.814Z. Source revision: 44c57cde5aeab97ff9bd1eaef20bbde4221b10a3. Capture scope: Current judge-story UI rendering of a consistent SQLite snapshot of the retained actual hosted run360c040e-16a1-4f81-ac76-1e1ec4ef6195. Authenticated GET-only loopback capture; model generation disabled, non-GET host routes rejected. No new inference, rebind or save. Previous public-input/control screenshots and actual composition/backup retain original dates; deployment UI banner is concurrently owned..</a:t>
+              <a:t>Retained original proof date: 2026-10-04T01:29:53.383Z. Retained intention proof date: 2026-10-04T02:07:09.266Z. Browser capture date: 2026-10-04T07:54:36.814Z. Source revision: f1565c23ff185cb87587c6108be96dbec243b5ce. Capture scope: Current judge-story UI rendering of a consistent SQLite snapshot of the retained actual hosted run360c040e-16a1-4f81-ac76-1e1ec4ef6195. Authenticated GET-only loopback capture; model generation disabled, non-GET host routes rejected. No new inference, rebind or save. Previous public-input/control screenshots and actual composition/backup retain original dates; deployment UI banner is concurrently owned.; README-only documentary rebind to this revision; UI bytes identical to44c; no new capture/inference/rebind/save.</a:t>
             </a:r>
           </a:p>
           <a:p xmlns:a="http://schemas.openxmlformats.org/drawingml/2006/main">
@@ -1185,7 +1185,7 @@
           </a:p>
           <a:p xmlns:a="http://schemas.openxmlformats.org/drawingml/2006/main">
             <a:r>
-              <a:t>Retained original proof date: 2026-10-04T01:29:53.383Z. Retained intention proof date: 2026-10-04T02:07:09.266Z. Browser capture date: 2026-10-04T07:54:36.814Z. Source revision: 44c57cde5aeab97ff9bd1eaef20bbde4221b10a3. Capture scope: Current judge-story UI rendering of a consistent SQLite snapshot of the retained actual hosted run360c040e-16a1-4f81-ac76-1e1ec4ef6195. Authenticated GET-only loopback capture; model generation disabled, non-GET host routes rejected. No new inference, rebind or save. Previous public-input/control screenshots and actual composition/backup retain original dates; deployment UI banner is concurrently owned..</a:t>
+              <a:t>Retained original proof date: 2026-10-04T01:29:53.383Z. Retained intention proof date: 2026-10-04T02:07:09.266Z. Browser capture date: 2026-10-04T07:54:36.814Z. Source revision: f1565c23ff185cb87587c6108be96dbec243b5ce. Capture scope: Current judge-story UI rendering of a consistent SQLite snapshot of the retained actual hosted run360c040e-16a1-4f81-ac76-1e1ec4ef6195. Authenticated GET-only loopback capture; model generation disabled, non-GET host routes rejected. No new inference, rebind or save. Previous public-input/control screenshots and actual composition/backup retain original dates; deployment UI banner is concurrently owned.; README-only documentary rebind to this revision; UI bytes identical to44c; no new capture/inference/rebind/save.</a:t>
             </a:r>
           </a:p>
           <a:p xmlns:a="http://schemas.openxmlformats.org/drawingml/2006/main">
@@ -1258,7 +1258,7 @@
   </p:cSld>
   <p:clrMap bg1="lt1" tx1="dk1" bg2="lt2" tx2="dk2" accent1="accent1" accent2="accent2" accent3="accent3" accent4="accent4" accent5="accent5" accent6="accent6" hlink="hlink" folHlink="folHlink"/>
   <p:sldLayoutIdLst>
-    <p:sldLayoutId xmlns:r="http://schemas.openxmlformats.org/officeDocument/2006/relationships" id="2147483649" r:id="R13d7497a580b4e59"/>
+    <p:sldLayoutId xmlns:r="http://schemas.openxmlformats.org/officeDocument/2006/relationships" id="2147483649" r:id="R20feae0d4c504136"/>
   </p:sldLayoutIdLst>
   <p:txStyles>
     <p:titleStyle>
@@ -1809,7 +1809,7 @@
           <p:cNvPr id="4" name="text-1">
             <a:extLst xmlns:a="http://schemas.openxmlformats.org/drawingml/2006/main">
               <a:ext uri="{FF2B5EF4-FFF2-40B4-BE49-F238E27FC236}">
-                <a16:creationId xmlns:a16="http://schemas.microsoft.com/office/drawing/2014/main" id="{6D5366C5-3877-41AC-9E11-02321C9EA115}"/>
+                <a16:creationId xmlns:a16="http://schemas.microsoft.com/office/drawing/2014/main" id="{F11DDF49-0800-4382-8695-8F0A36D34AB1}"/>
               </a:ext>
             </a:extLst>
           </p:cNvPr>
@@ -1866,7 +1866,7 @@
           <p:cNvPr id="2" name="text-2">
             <a:extLst xmlns:a="http://schemas.openxmlformats.org/drawingml/2006/main">
               <a:ext uri="{FF2B5EF4-FFF2-40B4-BE49-F238E27FC236}">
-                <a16:creationId xmlns:a16="http://schemas.microsoft.com/office/drawing/2014/main" id="{967E6AD5-FB72-4DDF-9010-6896F12F96ED}"/>
+                <a16:creationId xmlns:a16="http://schemas.microsoft.com/office/drawing/2014/main" id="{3A2D2521-5FC8-42AF-AB3D-2BA80AF398B1}"/>
               </a:ext>
             </a:extLst>
           </p:cNvPr>
@@ -1946,7 +1946,7 @@
           <p:cNvPr id="3" name="text-3">
             <a:extLst xmlns:a="http://schemas.openxmlformats.org/drawingml/2006/main">
               <a:ext uri="{FF2B5EF4-FFF2-40B4-BE49-F238E27FC236}">
-                <a16:creationId xmlns:a16="http://schemas.microsoft.com/office/drawing/2014/main" id="{D6512890-DD3D-42C4-B679-2302B49FBA10}"/>
+                <a16:creationId xmlns:a16="http://schemas.microsoft.com/office/drawing/2014/main" id="{F700AFE5-CED8-46C3-A589-67293A32C51A}"/>
               </a:ext>
             </a:extLst>
           </p:cNvPr>
@@ -2001,7 +2001,7 @@
     </p:spTree>
     <p:extLst>
       <p:ext uri="{BB962C8B-B14F-4D97-AF65-F5344CB8AC3E}">
-        <p14:creationId xmlns:p14="http://schemas.microsoft.com/office/powerpoint/2010/main" val="1341869447"/>
+        <p14:creationId xmlns:p14="http://schemas.microsoft.com/office/powerpoint/2010/main" val="2062351547"/>
       </p:ext>
     </p:extLst>
   </p:cSld>
@@ -2032,7 +2032,7 @@
           <p:cNvPr id="9" name="text-4">
             <a:extLst xmlns:a="http://schemas.openxmlformats.org/drawingml/2006/main">
               <a:ext uri="{FF2B5EF4-FFF2-40B4-BE49-F238E27FC236}">
-                <a16:creationId xmlns:a16="http://schemas.microsoft.com/office/drawing/2014/main" id="{E96EE5B7-D649-4A4A-8D20-F774607162BF}"/>
+                <a16:creationId xmlns:a16="http://schemas.microsoft.com/office/drawing/2014/main" id="{6D4E77AE-F60D-44DD-93A5-01DF460EDBE9}"/>
               </a:ext>
             </a:extLst>
           </p:cNvPr>
@@ -2089,7 +2089,7 @@
           <p:cNvPr id="2" name="text-5">
             <a:extLst xmlns:a="http://schemas.openxmlformats.org/drawingml/2006/main">
               <a:ext uri="{FF2B5EF4-FFF2-40B4-BE49-F238E27FC236}">
-                <a16:creationId xmlns:a16="http://schemas.microsoft.com/office/drawing/2014/main" id="{FAE3FA6F-9AC2-4943-A3BE-BA10BD3F7AD4}"/>
+                <a16:creationId xmlns:a16="http://schemas.microsoft.com/office/drawing/2014/main" id="{6B95B78C-86E8-46F3-940C-EB550F2FA29F}"/>
               </a:ext>
             </a:extLst>
           </p:cNvPr>
@@ -2146,7 +2146,7 @@
           <p:cNvPr id="3" name="text-6">
             <a:extLst xmlns:a="http://schemas.openxmlformats.org/drawingml/2006/main">
               <a:ext uri="{FF2B5EF4-FFF2-40B4-BE49-F238E27FC236}">
-                <a16:creationId xmlns:a16="http://schemas.microsoft.com/office/drawing/2014/main" id="{39E3FE06-FF8D-44EC-B3CC-2D7BB497AD84}"/>
+                <a16:creationId xmlns:a16="http://schemas.microsoft.com/office/drawing/2014/main" id="{62336D31-4387-49C5-98CE-B62D2C7BFD40}"/>
               </a:ext>
             </a:extLst>
           </p:cNvPr>
@@ -2249,7 +2249,7 @@
           <p:cNvPr id="4" name="text-7">
             <a:extLst xmlns:a="http://schemas.openxmlformats.org/drawingml/2006/main">
               <a:ext uri="{FF2B5EF4-FFF2-40B4-BE49-F238E27FC236}">
-                <a16:creationId xmlns:a16="http://schemas.microsoft.com/office/drawing/2014/main" id="{759B6C23-2D73-4C71-B7AB-F22CA631C617}"/>
+                <a16:creationId xmlns:a16="http://schemas.microsoft.com/office/drawing/2014/main" id="{CE59F3C6-1E5C-40DA-A5A5-AAD4E5E74795}"/>
               </a:ext>
             </a:extLst>
           </p:cNvPr>
@@ -2329,7 +2329,7 @@
           <p:cNvPr id="5" name="text-8">
             <a:extLst xmlns:a="http://schemas.openxmlformats.org/drawingml/2006/main">
               <a:ext uri="{FF2B5EF4-FFF2-40B4-BE49-F238E27FC236}">
-                <a16:creationId xmlns:a16="http://schemas.microsoft.com/office/drawing/2014/main" id="{60487845-6758-47E9-AA17-91CD608D7B75}"/>
+                <a16:creationId xmlns:a16="http://schemas.microsoft.com/office/drawing/2014/main" id="{49500EB3-0CE9-418A-B633-381EB16041D8}"/>
               </a:ext>
             </a:extLst>
           </p:cNvPr>
@@ -2386,7 +2386,7 @@
           <p:cNvPr id="6" name="text-9">
             <a:extLst xmlns:a="http://schemas.openxmlformats.org/drawingml/2006/main">
               <a:ext uri="{FF2B5EF4-FFF2-40B4-BE49-F238E27FC236}">
-                <a16:creationId xmlns:a16="http://schemas.microsoft.com/office/drawing/2014/main" id="{E9664668-164A-4154-96FB-320129B31225}"/>
+                <a16:creationId xmlns:a16="http://schemas.microsoft.com/office/drawing/2014/main" id="{F2613990-42A9-41B8-AD8B-B8ADEB328959}"/>
               </a:ext>
             </a:extLst>
           </p:cNvPr>
@@ -2489,7 +2489,7 @@
           <p:cNvPr id="7" name="text-10">
             <a:extLst xmlns:a="http://schemas.openxmlformats.org/drawingml/2006/main">
               <a:ext uri="{FF2B5EF4-FFF2-40B4-BE49-F238E27FC236}">
-                <a16:creationId xmlns:a16="http://schemas.microsoft.com/office/drawing/2014/main" id="{7CEF4C5D-5495-4046-8071-325943111C71}"/>
+                <a16:creationId xmlns:a16="http://schemas.microsoft.com/office/drawing/2014/main" id="{26C5B378-BB81-40E3-9013-D149A2A382B4}"/>
               </a:ext>
             </a:extLst>
           </p:cNvPr>
@@ -2569,7 +2569,7 @@
           <p:cNvPr id="8" name="text-11">
             <a:extLst xmlns:a="http://schemas.openxmlformats.org/drawingml/2006/main">
               <a:ext uri="{FF2B5EF4-FFF2-40B4-BE49-F238E27FC236}">
-                <a16:creationId xmlns:a16="http://schemas.microsoft.com/office/drawing/2014/main" id="{33F1860C-8EB1-4D45-A270-A1E3AF1701A4}"/>
+                <a16:creationId xmlns:a16="http://schemas.microsoft.com/office/drawing/2014/main" id="{0A52AC9E-08A4-497E-AE76-C457835BA46E}"/>
               </a:ext>
             </a:extLst>
           </p:cNvPr>
@@ -2624,7 +2624,7 @@
     </p:spTree>
     <p:extLst>
       <p:ext uri="{BB962C8B-B14F-4D97-AF65-F5344CB8AC3E}">
-        <p14:creationId xmlns:p14="http://schemas.microsoft.com/office/powerpoint/2010/main" val="223280764"/>
+        <p14:creationId xmlns:p14="http://schemas.microsoft.com/office/powerpoint/2010/main" val="532628508"/>
       </p:ext>
     </p:extLst>
   </p:cSld>
@@ -2655,7 +2655,7 @@
           <p:cNvPr id="7" name="text-12">
             <a:extLst xmlns:a="http://schemas.openxmlformats.org/drawingml/2006/main">
               <a:ext uri="{FF2B5EF4-FFF2-40B4-BE49-F238E27FC236}">
-                <a16:creationId xmlns:a16="http://schemas.microsoft.com/office/drawing/2014/main" id="{964E4375-FADE-4208-9CA6-19EA043C68A6}"/>
+                <a16:creationId xmlns:a16="http://schemas.microsoft.com/office/drawing/2014/main" id="{AD3B4A4D-C22A-49D1-8B84-8D29EE936567}"/>
               </a:ext>
             </a:extLst>
           </p:cNvPr>
@@ -2712,7 +2712,7 @@
           <p:cNvPr id="2" name="text-13">
             <a:extLst xmlns:a="http://schemas.openxmlformats.org/drawingml/2006/main">
               <a:ext uri="{FF2B5EF4-FFF2-40B4-BE49-F238E27FC236}">
-                <a16:creationId xmlns:a16="http://schemas.microsoft.com/office/drawing/2014/main" id="{87630308-2383-4FE0-A630-1FD5087A2607}"/>
+                <a16:creationId xmlns:a16="http://schemas.microsoft.com/office/drawing/2014/main" id="{B31EE726-2EF9-473D-A777-119ED7F7FB17}"/>
               </a:ext>
             </a:extLst>
           </p:cNvPr>
@@ -2769,7 +2769,7 @@
           <p:cNvPr id="3" name="text-14">
             <a:extLst xmlns:a="http://schemas.openxmlformats.org/drawingml/2006/main">
               <a:ext uri="{FF2B5EF4-FFF2-40B4-BE49-F238E27FC236}">
-                <a16:creationId xmlns:a16="http://schemas.microsoft.com/office/drawing/2014/main" id="{27B04038-BA60-4E88-B2A2-9B564C541531}"/>
+                <a16:creationId xmlns:a16="http://schemas.microsoft.com/office/drawing/2014/main" id="{71A8CFF9-1091-4F5F-80F1-0464394DE9DD}"/>
               </a:ext>
             </a:extLst>
           </p:cNvPr>
@@ -2895,7 +2895,7 @@
           <p:cNvPr id="4" name="text-15">
             <a:extLst xmlns:a="http://schemas.openxmlformats.org/drawingml/2006/main">
               <a:ext uri="{FF2B5EF4-FFF2-40B4-BE49-F238E27FC236}">
-                <a16:creationId xmlns:a16="http://schemas.microsoft.com/office/drawing/2014/main" id="{063D1585-7DC9-4E56-82B4-A3B827026834}"/>
+                <a16:creationId xmlns:a16="http://schemas.microsoft.com/office/drawing/2014/main" id="{6450ACF1-92C2-4366-8D94-DBBE8EA30ADC}"/>
               </a:ext>
             </a:extLst>
           </p:cNvPr>
@@ -2952,7 +2952,7 @@
           <p:cNvPr id="5" name="text-16">
             <a:extLst xmlns:a="http://schemas.openxmlformats.org/drawingml/2006/main">
               <a:ext uri="{FF2B5EF4-FFF2-40B4-BE49-F238E27FC236}">
-                <a16:creationId xmlns:a16="http://schemas.microsoft.com/office/drawing/2014/main" id="{889F189E-5DDD-450F-9FCE-B4BB77D16AFA}"/>
+                <a16:creationId xmlns:a16="http://schemas.microsoft.com/office/drawing/2014/main" id="{DFCA1302-2D5D-42FD-8114-28A5F53C8076}"/>
               </a:ext>
             </a:extLst>
           </p:cNvPr>
@@ -3101,7 +3101,7 @@
           <p:cNvPr id="6" name="text-17">
             <a:extLst xmlns:a="http://schemas.openxmlformats.org/drawingml/2006/main">
               <a:ext uri="{FF2B5EF4-FFF2-40B4-BE49-F238E27FC236}">
-                <a16:creationId xmlns:a16="http://schemas.microsoft.com/office/drawing/2014/main" id="{365995C5-BAD0-4E4D-87A8-2E11CFDB8759}"/>
+                <a16:creationId xmlns:a16="http://schemas.microsoft.com/office/drawing/2014/main" id="{44049E03-FD09-49A2-A0A5-89D3053796AE}"/>
               </a:ext>
             </a:extLst>
           </p:cNvPr>
@@ -3156,7 +3156,7 @@
     </p:spTree>
     <p:extLst>
       <p:ext uri="{BB962C8B-B14F-4D97-AF65-F5344CB8AC3E}">
-        <p14:creationId xmlns:p14="http://schemas.microsoft.com/office/powerpoint/2010/main" val="1988090216"/>
+        <p14:creationId xmlns:p14="http://schemas.microsoft.com/office/powerpoint/2010/main" val="1414575457"/>
       </p:ext>
     </p:extLst>
   </p:cSld>
@@ -3187,7 +3187,7 @@
           <p:cNvPr id="10" name="text-18">
             <a:extLst xmlns:a="http://schemas.openxmlformats.org/drawingml/2006/main">
               <a:ext uri="{FF2B5EF4-FFF2-40B4-BE49-F238E27FC236}">
-                <a16:creationId xmlns:a16="http://schemas.microsoft.com/office/drawing/2014/main" id="{18B43892-5014-41B8-B217-2AF6F353EC02}"/>
+                <a16:creationId xmlns:a16="http://schemas.microsoft.com/office/drawing/2014/main" id="{49437FEE-6A70-4223-AA4B-10E75CFFEE09}"/>
               </a:ext>
             </a:extLst>
           </p:cNvPr>
@@ -3244,7 +3244,7 @@
           <p:cNvPr id="2" name="text-19">
             <a:extLst xmlns:a="http://schemas.openxmlformats.org/drawingml/2006/main">
               <a:ext uri="{FF2B5EF4-FFF2-40B4-BE49-F238E27FC236}">
-                <a16:creationId xmlns:a16="http://schemas.microsoft.com/office/drawing/2014/main" id="{A198911D-FB75-44A2-9E71-8426D07E5D1F}"/>
+                <a16:creationId xmlns:a16="http://schemas.microsoft.com/office/drawing/2014/main" id="{22FFBF01-D7F3-4A71-B3F5-28E7820E1BF8}"/>
               </a:ext>
             </a:extLst>
           </p:cNvPr>
@@ -3301,7 +3301,7 @@
           <p:cNvPr id="3" name="text-20">
             <a:extLst xmlns:a="http://schemas.openxmlformats.org/drawingml/2006/main">
               <a:ext uri="{FF2B5EF4-FFF2-40B4-BE49-F238E27FC236}">
-                <a16:creationId xmlns:a16="http://schemas.microsoft.com/office/drawing/2014/main" id="{B5C21E72-33D4-4834-A9F6-F3E4EE5E6FF1}"/>
+                <a16:creationId xmlns:a16="http://schemas.microsoft.com/office/drawing/2014/main" id="{3DE25B41-FAE6-4395-B120-146F2DEE5662}"/>
               </a:ext>
             </a:extLst>
           </p:cNvPr>
@@ -3358,7 +3358,7 @@
           <p:cNvPr id="4" name="text-21">
             <a:extLst xmlns:a="http://schemas.openxmlformats.org/drawingml/2006/main">
               <a:ext uri="{FF2B5EF4-FFF2-40B4-BE49-F238E27FC236}">
-                <a16:creationId xmlns:a16="http://schemas.microsoft.com/office/drawing/2014/main" id="{1E175E71-B76D-45F5-9234-5BB14A7EAE80}"/>
+                <a16:creationId xmlns:a16="http://schemas.microsoft.com/office/drawing/2014/main" id="{10227E02-6794-4DAD-8215-89114FCD72E7}"/>
               </a:ext>
             </a:extLst>
           </p:cNvPr>
@@ -3415,7 +3415,7 @@
           <p:cNvPr id="5" name="text-22">
             <a:extLst xmlns:a="http://schemas.openxmlformats.org/drawingml/2006/main">
               <a:ext uri="{FF2B5EF4-FFF2-40B4-BE49-F238E27FC236}">
-                <a16:creationId xmlns:a16="http://schemas.microsoft.com/office/drawing/2014/main" id="{775082BE-1C92-42E6-8EF8-17B1FB20DF31}"/>
+                <a16:creationId xmlns:a16="http://schemas.microsoft.com/office/drawing/2014/main" id="{1C4A6338-026F-43AF-A7B6-15E4AA4B6526}"/>
               </a:ext>
             </a:extLst>
           </p:cNvPr>
@@ -3472,7 +3472,7 @@
           <p:cNvPr id="6" name="text-23">
             <a:extLst xmlns:a="http://schemas.openxmlformats.org/drawingml/2006/main">
               <a:ext uri="{FF2B5EF4-FFF2-40B4-BE49-F238E27FC236}">
-                <a16:creationId xmlns:a16="http://schemas.microsoft.com/office/drawing/2014/main" id="{DFE7EF34-CD58-44AA-B4F9-3823F490ABD3}"/>
+                <a16:creationId xmlns:a16="http://schemas.microsoft.com/office/drawing/2014/main" id="{F6DEE47C-96FA-4C4F-9E70-4CFE61E1B38F}"/>
               </a:ext>
             </a:extLst>
           </p:cNvPr>
@@ -3552,7 +3552,7 @@
           <p:cNvPr id="7" name="text-24">
             <a:extLst xmlns:a="http://schemas.openxmlformats.org/drawingml/2006/main">
               <a:ext uri="{FF2B5EF4-FFF2-40B4-BE49-F238E27FC236}">
-                <a16:creationId xmlns:a16="http://schemas.microsoft.com/office/drawing/2014/main" id="{D065A64E-0389-4BBE-B213-59A650E1C4EF}"/>
+                <a16:creationId xmlns:a16="http://schemas.microsoft.com/office/drawing/2014/main" id="{2785CF7A-5D9A-4960-AB61-BE098877FDE1}"/>
               </a:ext>
             </a:extLst>
           </p:cNvPr>
@@ -3613,7 +3613,7 @@
           <p:nvPr/>
         </p:nvPicPr>
         <p:blipFill>
-          <a:blip xmlns:r="http://schemas.openxmlformats.org/officeDocument/2006/relationships" xmlns:a="http://schemas.openxmlformats.org/drawingml/2006/main" r:embed="R861d38d4b83f4cc1"/>
+          <a:blip xmlns:r="http://schemas.openxmlformats.org/officeDocument/2006/relationships" xmlns:a="http://schemas.openxmlformats.org/drawingml/2006/main" r:embed="R049f58a3b7ed4f67"/>
           <a:stretch xmlns:a="http://schemas.openxmlformats.org/drawingml/2006/main"/>
         </p:blipFill>
         <p:spPr>
@@ -3631,7 +3631,7 @@
           <p:cNvPr id="9" name="text-25">
             <a:extLst xmlns:a="http://schemas.openxmlformats.org/drawingml/2006/main">
               <a:ext uri="{FF2B5EF4-FFF2-40B4-BE49-F238E27FC236}">
-                <a16:creationId xmlns:a16="http://schemas.microsoft.com/office/drawing/2014/main" id="{273F5650-7FBA-4AC7-AE1B-48283D216A88}"/>
+                <a16:creationId xmlns:a16="http://schemas.microsoft.com/office/drawing/2014/main" id="{BBE0B5CF-A7A9-4C8A-A1B8-ED0A5FFFF195}"/>
               </a:ext>
             </a:extLst>
           </p:cNvPr>
@@ -3686,7 +3686,7 @@
     </p:spTree>
     <p:extLst>
       <p:ext uri="{BB962C8B-B14F-4D97-AF65-F5344CB8AC3E}">
-        <p14:creationId xmlns:p14="http://schemas.microsoft.com/office/powerpoint/2010/main" val="620449471"/>
+        <p14:creationId xmlns:p14="http://schemas.microsoft.com/office/powerpoint/2010/main" val="415543206"/>
       </p:ext>
     </p:extLst>
   </p:cSld>
@@ -3717,7 +3717,7 @@
           <p:cNvPr id="16" name="text-26">
             <a:extLst xmlns:a="http://schemas.openxmlformats.org/drawingml/2006/main">
               <a:ext uri="{FF2B5EF4-FFF2-40B4-BE49-F238E27FC236}">
-                <a16:creationId xmlns:a16="http://schemas.microsoft.com/office/drawing/2014/main" id="{15AB9691-24C2-4EC8-8CDB-27EF6A4D05A3}"/>
+                <a16:creationId xmlns:a16="http://schemas.microsoft.com/office/drawing/2014/main" id="{D4D39F4B-04D1-4996-97B0-0082AE3B1666}"/>
               </a:ext>
             </a:extLst>
           </p:cNvPr>
@@ -3774,7 +3774,7 @@
           <p:cNvPr id="2" name="text-27">
             <a:extLst xmlns:a="http://schemas.openxmlformats.org/drawingml/2006/main">
               <a:ext uri="{FF2B5EF4-FFF2-40B4-BE49-F238E27FC236}">
-                <a16:creationId xmlns:a16="http://schemas.microsoft.com/office/drawing/2014/main" id="{0C2DEFCB-B7DF-488C-AC64-FBB2BF7E1D0E}"/>
+                <a16:creationId xmlns:a16="http://schemas.microsoft.com/office/drawing/2014/main" id="{07492AAB-2662-4897-9FEA-0E43FC0EB4D6}"/>
               </a:ext>
             </a:extLst>
           </p:cNvPr>
@@ -3831,7 +3831,7 @@
           <p:cNvPr id="3" name="mechanism-28">
             <a:extLst xmlns:a="http://schemas.openxmlformats.org/drawingml/2006/main">
               <a:ext uri="{FF2B5EF4-FFF2-40B4-BE49-F238E27FC236}">
-                <a16:creationId xmlns:a16="http://schemas.microsoft.com/office/drawing/2014/main" id="{D920A20C-2A60-447E-AAC2-394A7107FCED}"/>
+                <a16:creationId xmlns:a16="http://schemas.microsoft.com/office/drawing/2014/main" id="{4CA69C7E-41F9-46CD-9E88-DAC29322614A}"/>
               </a:ext>
             </a:extLst>
           </p:cNvPr>
@@ -3916,7 +3916,7 @@
           <p:cNvPr id="4" name="mechanism-29">
             <a:extLst xmlns:a="http://schemas.openxmlformats.org/drawingml/2006/main">
               <a:ext uri="{FF2B5EF4-FFF2-40B4-BE49-F238E27FC236}">
-                <a16:creationId xmlns:a16="http://schemas.microsoft.com/office/drawing/2014/main" id="{90F6B6F9-3997-41A3-A04D-21F50BB5823E}"/>
+                <a16:creationId xmlns:a16="http://schemas.microsoft.com/office/drawing/2014/main" id="{7C4A3E36-4FA1-48D3-BBEF-D4CCE1D4942C}"/>
               </a:ext>
             </a:extLst>
           </p:cNvPr>
@@ -4024,7 +4024,7 @@
           <p:cNvPr id="5" name="mechanism-30">
             <a:extLst xmlns:a="http://schemas.openxmlformats.org/drawingml/2006/main">
               <a:ext uri="{FF2B5EF4-FFF2-40B4-BE49-F238E27FC236}">
-                <a16:creationId xmlns:a16="http://schemas.microsoft.com/office/drawing/2014/main" id="{3F41A89C-7C21-42B0-99A8-D9C568902A5C}"/>
+                <a16:creationId xmlns:a16="http://schemas.microsoft.com/office/drawing/2014/main" id="{8BE42A84-D14A-4ED2-A4B6-6557A922F4FA}"/>
               </a:ext>
             </a:extLst>
           </p:cNvPr>
@@ -4161,7 +4161,7 @@
           <p:cNvPr id="8" name="text-31">
             <a:extLst xmlns:a="http://schemas.openxmlformats.org/drawingml/2006/main">
               <a:ext uri="{FF2B5EF4-FFF2-40B4-BE49-F238E27FC236}">
-                <a16:creationId xmlns:a16="http://schemas.microsoft.com/office/drawing/2014/main" id="{2C5FEA4C-C619-4792-8EAE-B25144EF6BB0}"/>
+                <a16:creationId xmlns:a16="http://schemas.microsoft.com/office/drawing/2014/main" id="{D25E91B1-4353-4A17-B812-A4B33CA4C542}"/>
               </a:ext>
             </a:extLst>
           </p:cNvPr>
@@ -4218,7 +4218,7 @@
           <p:cNvPr id="9" name="mechanism-32">
             <a:extLst xmlns:a="http://schemas.openxmlformats.org/drawingml/2006/main">
               <a:ext uri="{FF2B5EF4-FFF2-40B4-BE49-F238E27FC236}">
-                <a16:creationId xmlns:a16="http://schemas.microsoft.com/office/drawing/2014/main" id="{D1D28B2C-28B0-4E94-9EE0-198609C7302A}"/>
+                <a16:creationId xmlns:a16="http://schemas.microsoft.com/office/drawing/2014/main" id="{86C35233-BDE9-4064-BA76-5CEC2D5439FE}"/>
               </a:ext>
             </a:extLst>
           </p:cNvPr>
@@ -4303,7 +4303,7 @@
           <p:cNvPr id="10" name="mechanism-33">
             <a:extLst xmlns:a="http://schemas.openxmlformats.org/drawingml/2006/main">
               <a:ext uri="{FF2B5EF4-FFF2-40B4-BE49-F238E27FC236}">
-                <a16:creationId xmlns:a16="http://schemas.microsoft.com/office/drawing/2014/main" id="{9BC014FE-DFD0-41FD-8C62-B89E6BF6AD7A}"/>
+                <a16:creationId xmlns:a16="http://schemas.microsoft.com/office/drawing/2014/main" id="{8BE69EA4-A85E-4083-B364-2D0666DD72E6}"/>
               </a:ext>
             </a:extLst>
           </p:cNvPr>
@@ -4388,7 +4388,7 @@
           <p:cNvPr id="11" name="mechanism-34">
             <a:extLst xmlns:a="http://schemas.openxmlformats.org/drawingml/2006/main">
               <a:ext uri="{FF2B5EF4-FFF2-40B4-BE49-F238E27FC236}">
-                <a16:creationId xmlns:a16="http://schemas.microsoft.com/office/drawing/2014/main" id="{29007595-8937-48EB-961A-675430C494AF}"/>
+                <a16:creationId xmlns:a16="http://schemas.microsoft.com/office/drawing/2014/main" id="{A6DBBA01-B1CE-467C-8CC6-9DCC1B17CF34}"/>
               </a:ext>
             </a:extLst>
           </p:cNvPr>
@@ -4574,7 +4574,7 @@
           <p:cNvPr id="15" name="text-35">
             <a:extLst xmlns:a="http://schemas.openxmlformats.org/drawingml/2006/main">
               <a:ext uri="{FF2B5EF4-FFF2-40B4-BE49-F238E27FC236}">
-                <a16:creationId xmlns:a16="http://schemas.microsoft.com/office/drawing/2014/main" id="{ABF0580A-56F9-4CA1-B2B6-5231A0F0D24A}"/>
+                <a16:creationId xmlns:a16="http://schemas.microsoft.com/office/drawing/2014/main" id="{EB6D1332-D6CD-4781-A1EC-E60CDDAAD16D}"/>
               </a:ext>
             </a:extLst>
           </p:cNvPr>
@@ -4629,7 +4629,7 @@
     </p:spTree>
     <p:extLst>
       <p:ext uri="{BB962C8B-B14F-4D97-AF65-F5344CB8AC3E}">
-        <p14:creationId xmlns:p14="http://schemas.microsoft.com/office/powerpoint/2010/main" val="775573497"/>
+        <p14:creationId xmlns:p14="http://schemas.microsoft.com/office/powerpoint/2010/main" val="1447046964"/>
       </p:ext>
     </p:extLst>
   </p:cSld>
@@ -4660,7 +4660,7 @@
           <p:cNvPr id="7" name="text-36">
             <a:extLst xmlns:a="http://schemas.openxmlformats.org/drawingml/2006/main">
               <a:ext uri="{FF2B5EF4-FFF2-40B4-BE49-F238E27FC236}">
-                <a16:creationId xmlns:a16="http://schemas.microsoft.com/office/drawing/2014/main" id="{CB1F5D67-97FC-4D03-9B3F-1034F3BA1A4C}"/>
+                <a16:creationId xmlns:a16="http://schemas.microsoft.com/office/drawing/2014/main" id="{4C4B493F-E4A9-4E07-A2AA-67C39CE2C23D}"/>
               </a:ext>
             </a:extLst>
           </p:cNvPr>
@@ -4721,7 +4721,7 @@
           <p:nvPr/>
         </p:nvPicPr>
         <p:blipFill>
-          <a:blip xmlns:r="http://schemas.openxmlformats.org/officeDocument/2006/relationships" xmlns:a="http://schemas.openxmlformats.org/drawingml/2006/main" r:embed="R7f53c38106a5475c"/>
+          <a:blip xmlns:r="http://schemas.openxmlformats.org/officeDocument/2006/relationships" xmlns:a="http://schemas.openxmlformats.org/drawingml/2006/main" r:embed="Rb3da4c814b9a4055"/>
           <a:stretch xmlns:a="http://schemas.openxmlformats.org/drawingml/2006/main"/>
         </p:blipFill>
         <p:spPr>
@@ -4739,7 +4739,7 @@
           <p:cNvPr id="3" name="text-37">
             <a:extLst xmlns:a="http://schemas.openxmlformats.org/drawingml/2006/main">
               <a:ext uri="{FF2B5EF4-FFF2-40B4-BE49-F238E27FC236}">
-                <a16:creationId xmlns:a16="http://schemas.microsoft.com/office/drawing/2014/main" id="{74898AB4-1FB7-414C-ABD2-9F06D3101B23}"/>
+                <a16:creationId xmlns:a16="http://schemas.microsoft.com/office/drawing/2014/main" id="{647DDEA1-D527-4B79-9DD1-65516EDA179A}"/>
               </a:ext>
             </a:extLst>
           </p:cNvPr>
@@ -4796,7 +4796,7 @@
           <p:cNvPr id="4" name="text-38">
             <a:extLst xmlns:a="http://schemas.openxmlformats.org/drawingml/2006/main">
               <a:ext uri="{FF2B5EF4-FFF2-40B4-BE49-F238E27FC236}">
-                <a16:creationId xmlns:a16="http://schemas.microsoft.com/office/drawing/2014/main" id="{62841EF8-2C54-47D1-8C7C-E21CBAB0AC42}"/>
+                <a16:creationId xmlns:a16="http://schemas.microsoft.com/office/drawing/2014/main" id="{55794A56-F4E8-44A3-98AD-E7DAFEDE9750}"/>
               </a:ext>
             </a:extLst>
           </p:cNvPr>
@@ -4899,7 +4899,7 @@
           <p:cNvPr id="5" name="text-39">
             <a:extLst xmlns:a="http://schemas.openxmlformats.org/drawingml/2006/main">
               <a:ext uri="{FF2B5EF4-FFF2-40B4-BE49-F238E27FC236}">
-                <a16:creationId xmlns:a16="http://schemas.microsoft.com/office/drawing/2014/main" id="{ED64070F-5D79-4504-BEEB-DC87AEA4DFC8}"/>
+                <a16:creationId xmlns:a16="http://schemas.microsoft.com/office/drawing/2014/main" id="{E0CBF079-5802-48A1-A1AE-44034CB473FC}"/>
               </a:ext>
             </a:extLst>
           </p:cNvPr>
@@ -5002,7 +5002,7 @@
           <p:cNvPr id="6" name="text-40">
             <a:extLst xmlns:a="http://schemas.openxmlformats.org/drawingml/2006/main">
               <a:ext uri="{FF2B5EF4-FFF2-40B4-BE49-F238E27FC236}">
-                <a16:creationId xmlns:a16="http://schemas.microsoft.com/office/drawing/2014/main" id="{88B21816-91D2-4E80-8673-7B94F59B31CE}"/>
+                <a16:creationId xmlns:a16="http://schemas.microsoft.com/office/drawing/2014/main" id="{67BDE9BF-75FE-48F0-ADCB-AF3A72EE2BAA}"/>
               </a:ext>
             </a:extLst>
           </p:cNvPr>
@@ -5057,7 +5057,7 @@
     </p:spTree>
     <p:extLst>
       <p:ext uri="{BB962C8B-B14F-4D97-AF65-F5344CB8AC3E}">
-        <p14:creationId xmlns:p14="http://schemas.microsoft.com/office/powerpoint/2010/main" val="2062279647"/>
+        <p14:creationId xmlns:p14="http://schemas.microsoft.com/office/powerpoint/2010/main" val="462551977"/>
       </p:ext>
     </p:extLst>
   </p:cSld>
@@ -5088,7 +5088,7 @@
           <p:cNvPr id="9" name="text-41">
             <a:extLst xmlns:a="http://schemas.openxmlformats.org/drawingml/2006/main">
               <a:ext uri="{FF2B5EF4-FFF2-40B4-BE49-F238E27FC236}">
-                <a16:creationId xmlns:a16="http://schemas.microsoft.com/office/drawing/2014/main" id="{E0960EED-1F4B-46A2-9F83-A3F153B6BEF4}"/>
+                <a16:creationId xmlns:a16="http://schemas.microsoft.com/office/drawing/2014/main" id="{27A98DA8-C97A-4302-B763-88D179FD7C11}"/>
               </a:ext>
             </a:extLst>
           </p:cNvPr>
@@ -5145,7 +5145,7 @@
           <p:cNvPr id="2" name="text-42">
             <a:extLst xmlns:a="http://schemas.openxmlformats.org/drawingml/2006/main">
               <a:ext uri="{FF2B5EF4-FFF2-40B4-BE49-F238E27FC236}">
-                <a16:creationId xmlns:a16="http://schemas.microsoft.com/office/drawing/2014/main" id="{1D5ECA0B-EB1A-4095-995A-62C2EA55A235}"/>
+                <a16:creationId xmlns:a16="http://schemas.microsoft.com/office/drawing/2014/main" id="{5F489826-7C7E-462C-9E64-0110EF06966A}"/>
               </a:ext>
             </a:extLst>
           </p:cNvPr>
@@ -5202,7 +5202,7 @@
           <p:cNvPr id="3" name="text-43">
             <a:extLst xmlns:a="http://schemas.openxmlformats.org/drawingml/2006/main">
               <a:ext uri="{FF2B5EF4-FFF2-40B4-BE49-F238E27FC236}">
-                <a16:creationId xmlns:a16="http://schemas.microsoft.com/office/drawing/2014/main" id="{AA896FBB-51BB-4C40-A2BC-55029DB76537}"/>
+                <a16:creationId xmlns:a16="http://schemas.microsoft.com/office/drawing/2014/main" id="{A403410B-363D-4EC2-BAD6-5A19883A0250}"/>
               </a:ext>
             </a:extLst>
           </p:cNvPr>
@@ -5282,7 +5282,7 @@
           <p:cNvPr id="4" name="text-44">
             <a:extLst xmlns:a="http://schemas.openxmlformats.org/drawingml/2006/main">
               <a:ext uri="{FF2B5EF4-FFF2-40B4-BE49-F238E27FC236}">
-                <a16:creationId xmlns:a16="http://schemas.microsoft.com/office/drawing/2014/main" id="{C1C10EA1-5E52-4B9B-A77B-726D9754C9E8}"/>
+                <a16:creationId xmlns:a16="http://schemas.microsoft.com/office/drawing/2014/main" id="{95E4C036-55EF-4669-8BAE-7AA934E488D1}"/>
               </a:ext>
             </a:extLst>
           </p:cNvPr>
@@ -5385,7 +5385,7 @@
           <p:cNvPr id="5" name="text-45">
             <a:extLst xmlns:a="http://schemas.openxmlformats.org/drawingml/2006/main">
               <a:ext uri="{FF2B5EF4-FFF2-40B4-BE49-F238E27FC236}">
-                <a16:creationId xmlns:a16="http://schemas.microsoft.com/office/drawing/2014/main" id="{859F492F-1A2F-469C-9B98-0BFD77F1B101}"/>
+                <a16:creationId xmlns:a16="http://schemas.microsoft.com/office/drawing/2014/main" id="{DC2DBA41-D77F-413E-ABFB-FDD49D808FF0}"/>
               </a:ext>
             </a:extLst>
           </p:cNvPr>
@@ -5469,7 +5469,7 @@
           <p:nvPr/>
         </p:nvPicPr>
         <p:blipFill>
-          <a:blip xmlns:r="http://schemas.openxmlformats.org/officeDocument/2006/relationships" xmlns:a="http://schemas.openxmlformats.org/drawingml/2006/main" r:embed="Rd24123724671439b"/>
+          <a:blip xmlns:r="http://schemas.openxmlformats.org/officeDocument/2006/relationships" xmlns:a="http://schemas.openxmlformats.org/drawingml/2006/main" r:embed="Ra8bdb9041d904a7b"/>
           <a:stretch xmlns:a="http://schemas.openxmlformats.org/drawingml/2006/main"/>
         </p:blipFill>
         <p:spPr>
@@ -5487,7 +5487,7 @@
           <p:cNvPr id="7" name="text-46">
             <a:extLst xmlns:a="http://schemas.openxmlformats.org/drawingml/2006/main">
               <a:ext uri="{FF2B5EF4-FFF2-40B4-BE49-F238E27FC236}">
-                <a16:creationId xmlns:a16="http://schemas.microsoft.com/office/drawing/2014/main" id="{AC555986-6473-4EB7-9FBD-159C70EC461A}"/>
+                <a16:creationId xmlns:a16="http://schemas.microsoft.com/office/drawing/2014/main" id="{0978CF78-F576-4760-B6D6-05FF7032915D}"/>
               </a:ext>
             </a:extLst>
           </p:cNvPr>
@@ -5590,7 +5590,7 @@
           <p:cNvPr id="8" name="text-47">
             <a:extLst xmlns:a="http://schemas.openxmlformats.org/drawingml/2006/main">
               <a:ext uri="{FF2B5EF4-FFF2-40B4-BE49-F238E27FC236}">
-                <a16:creationId xmlns:a16="http://schemas.microsoft.com/office/drawing/2014/main" id="{C4E5DC2D-6188-4042-B05C-68CF8A2F3EC2}"/>
+                <a16:creationId xmlns:a16="http://schemas.microsoft.com/office/drawing/2014/main" id="{4390747E-3633-449E-9A38-AD63C18956D1}"/>
               </a:ext>
             </a:extLst>
           </p:cNvPr>
@@ -5645,7 +5645,7 @@
     </p:spTree>
     <p:extLst>
       <p:ext uri="{BB962C8B-B14F-4D97-AF65-F5344CB8AC3E}">
-        <p14:creationId xmlns:p14="http://schemas.microsoft.com/office/powerpoint/2010/main" val="1670797165"/>
+        <p14:creationId xmlns:p14="http://schemas.microsoft.com/office/powerpoint/2010/main" val="363314864"/>
       </p:ext>
     </p:extLst>
   </p:cSld>
@@ -5676,7 +5676,7 @@
           <p:cNvPr id="9" name="text-48">
             <a:extLst xmlns:a="http://schemas.openxmlformats.org/drawingml/2006/main">
               <a:ext uri="{FF2B5EF4-FFF2-40B4-BE49-F238E27FC236}">
-                <a16:creationId xmlns:a16="http://schemas.microsoft.com/office/drawing/2014/main" id="{8103F26F-E47C-46E0-A1F2-C6B2A2D0DC3A}"/>
+                <a16:creationId xmlns:a16="http://schemas.microsoft.com/office/drawing/2014/main" id="{718923FA-D537-4BA5-9429-633E378A6AF3}"/>
               </a:ext>
             </a:extLst>
           </p:cNvPr>
@@ -5733,7 +5733,7 @@
           <p:cNvPr id="2" name="text-49">
             <a:extLst xmlns:a="http://schemas.openxmlformats.org/drawingml/2006/main">
               <a:ext uri="{FF2B5EF4-FFF2-40B4-BE49-F238E27FC236}">
-                <a16:creationId xmlns:a16="http://schemas.microsoft.com/office/drawing/2014/main" id="{40344203-D62A-4847-A9D5-16C6F028C7A4}"/>
+                <a16:creationId xmlns:a16="http://schemas.microsoft.com/office/drawing/2014/main" id="{B44EE739-BD99-481B-B2CF-5FEC60873730}"/>
               </a:ext>
             </a:extLst>
           </p:cNvPr>
@@ -5790,7 +5790,7 @@
           <p:cNvPr id="3" name="text-50">
             <a:extLst xmlns:a="http://schemas.openxmlformats.org/drawingml/2006/main">
               <a:ext uri="{FF2B5EF4-FFF2-40B4-BE49-F238E27FC236}">
-                <a16:creationId xmlns:a16="http://schemas.microsoft.com/office/drawing/2014/main" id="{8A0A712B-6C72-4714-AD4A-AF3470464F60}"/>
+                <a16:creationId xmlns:a16="http://schemas.microsoft.com/office/drawing/2014/main" id="{CE7B0921-84AA-431A-8E7A-7CA121D7279F}"/>
               </a:ext>
             </a:extLst>
           </p:cNvPr>
@@ -5916,7 +5916,7 @@
           <p:cNvPr id="4" name="text-51">
             <a:extLst xmlns:a="http://schemas.openxmlformats.org/drawingml/2006/main">
               <a:ext uri="{FF2B5EF4-FFF2-40B4-BE49-F238E27FC236}">
-                <a16:creationId xmlns:a16="http://schemas.microsoft.com/office/drawing/2014/main" id="{B2F8DE01-4DE5-4C7C-9667-0616690D177B}"/>
+                <a16:creationId xmlns:a16="http://schemas.microsoft.com/office/drawing/2014/main" id="{068EF590-3E98-4B48-AEC4-4A92EDE2DAA1}"/>
               </a:ext>
             </a:extLst>
           </p:cNvPr>
@@ -5996,7 +5996,7 @@
           <p:cNvPr id="5" name="text-52">
             <a:extLst xmlns:a="http://schemas.openxmlformats.org/drawingml/2006/main">
               <a:ext uri="{FF2B5EF4-FFF2-40B4-BE49-F238E27FC236}">
-                <a16:creationId xmlns:a16="http://schemas.microsoft.com/office/drawing/2014/main" id="{10A84E15-57CB-4107-9CFD-3DCAD2B338C4}"/>
+                <a16:creationId xmlns:a16="http://schemas.microsoft.com/office/drawing/2014/main" id="{06393B3B-BFAE-44BF-8495-E3158E439A31}"/>
               </a:ext>
             </a:extLst>
           </p:cNvPr>
@@ -6076,7 +6076,7 @@
           <p:cNvPr id="6" name="text-53">
             <a:extLst xmlns:a="http://schemas.openxmlformats.org/drawingml/2006/main">
               <a:ext uri="{FF2B5EF4-FFF2-40B4-BE49-F238E27FC236}">
-                <a16:creationId xmlns:a16="http://schemas.microsoft.com/office/drawing/2014/main" id="{C566A640-B823-418E-BB78-33CF8817711D}"/>
+                <a16:creationId xmlns:a16="http://schemas.microsoft.com/office/drawing/2014/main" id="{7122C2FA-805C-4F3C-82BA-24FE0939D643}"/>
               </a:ext>
             </a:extLst>
           </p:cNvPr>
@@ -6133,7 +6133,7 @@
           <p:cNvPr id="7" name="text-54">
             <a:extLst xmlns:a="http://schemas.openxmlformats.org/drawingml/2006/main">
               <a:ext uri="{FF2B5EF4-FFF2-40B4-BE49-F238E27FC236}">
-                <a16:creationId xmlns:a16="http://schemas.microsoft.com/office/drawing/2014/main" id="{B75097BC-AB51-45A5-A103-F54D9F197D38}"/>
+                <a16:creationId xmlns:a16="http://schemas.microsoft.com/office/drawing/2014/main" id="{45688AE7-13D2-451D-98AB-72957426F8A4}"/>
               </a:ext>
             </a:extLst>
           </p:cNvPr>
@@ -6282,7 +6282,7 @@
           <p:cNvPr id="8" name="text-55">
             <a:extLst xmlns:a="http://schemas.openxmlformats.org/drawingml/2006/main">
               <a:ext uri="{FF2B5EF4-FFF2-40B4-BE49-F238E27FC236}">
-                <a16:creationId xmlns:a16="http://schemas.microsoft.com/office/drawing/2014/main" id="{9B14D1FC-E3C0-4DF1-9D59-4B942774676B}"/>
+                <a16:creationId xmlns:a16="http://schemas.microsoft.com/office/drawing/2014/main" id="{E3AB681B-746F-4208-9949-BE5052265B88}"/>
               </a:ext>
             </a:extLst>
           </p:cNvPr>
@@ -6383,7 +6383,7 @@
     </p:spTree>
     <p:extLst>
       <p:ext uri="{BB962C8B-B14F-4D97-AF65-F5344CB8AC3E}">
-        <p14:creationId xmlns:p14="http://schemas.microsoft.com/office/powerpoint/2010/main" val="28184113"/>
+        <p14:creationId xmlns:p14="http://schemas.microsoft.com/office/powerpoint/2010/main" val="554959966"/>
       </p:ext>
     </p:extLst>
   </p:cSld>
@@ -6414,7 +6414,7 @@
           <p:cNvPr id="5" name="text-56">
             <a:extLst xmlns:a="http://schemas.openxmlformats.org/drawingml/2006/main">
               <a:ext uri="{FF2B5EF4-FFF2-40B4-BE49-F238E27FC236}">
-                <a16:creationId xmlns:a16="http://schemas.microsoft.com/office/drawing/2014/main" id="{B2FAE18C-F2ED-4297-A09B-5B752E66B29A}"/>
+                <a16:creationId xmlns:a16="http://schemas.microsoft.com/office/drawing/2014/main" id="{557FC1FC-6FC9-46C0-A9D8-135BA650DA44}"/>
               </a:ext>
             </a:extLst>
           </p:cNvPr>
@@ -6494,7 +6494,7 @@
           <p:cNvPr id="2" name="text-57">
             <a:extLst xmlns:a="http://schemas.openxmlformats.org/drawingml/2006/main">
               <a:ext uri="{FF2B5EF4-FFF2-40B4-BE49-F238E27FC236}">
-                <a16:creationId xmlns:a16="http://schemas.microsoft.com/office/drawing/2014/main" id="{66A98DAA-2F15-4C37-B466-F7D95FAFD4E4}"/>
+                <a16:creationId xmlns:a16="http://schemas.microsoft.com/office/drawing/2014/main" id="{FFECFEF0-9053-444B-96AD-5A1826EEE5AC}"/>
               </a:ext>
             </a:extLst>
           </p:cNvPr>
@@ -6574,7 +6574,7 @@
           <p:cNvPr id="3" name="text-58">
             <a:extLst xmlns:a="http://schemas.openxmlformats.org/drawingml/2006/main">
               <a:ext uri="{FF2B5EF4-FFF2-40B4-BE49-F238E27FC236}">
-                <a16:creationId xmlns:a16="http://schemas.microsoft.com/office/drawing/2014/main" id="{9C752093-1693-477A-B06E-B5055935BC5F}"/>
+                <a16:creationId xmlns:a16="http://schemas.microsoft.com/office/drawing/2014/main" id="{27AC0188-1DA8-4437-9429-CC3237CE5E03}"/>
               </a:ext>
             </a:extLst>
           </p:cNvPr>
@@ -6631,7 +6631,7 @@
           <p:cNvPr id="4" name="text-59">
             <a:extLst xmlns:a="http://schemas.openxmlformats.org/drawingml/2006/main">
               <a:ext uri="{FF2B5EF4-FFF2-40B4-BE49-F238E27FC236}">
-                <a16:creationId xmlns:a16="http://schemas.microsoft.com/office/drawing/2014/main" id="{32AB9294-2A90-4F3D-BE94-5B7A40EF1ACA}"/>
+                <a16:creationId xmlns:a16="http://schemas.microsoft.com/office/drawing/2014/main" id="{7E7B9D5F-99E8-49F4-A9C6-17A6412D2B0E}"/>
               </a:ext>
             </a:extLst>
           </p:cNvPr>
@@ -6709,7 +6709,7 @@
     </p:spTree>
     <p:extLst>
       <p:ext uri="{BB962C8B-B14F-4D97-AF65-F5344CB8AC3E}">
-        <p14:creationId xmlns:p14="http://schemas.microsoft.com/office/powerpoint/2010/main" val="1111055935"/>
+        <p14:creationId xmlns:p14="http://schemas.microsoft.com/office/powerpoint/2010/main" val="79471968"/>
       </p:ext>
     </p:extLst>
   </p:cSld>

</xml_diff>